<commit_message>
docs: Add LaTeX (.tex), BibTeX (.bib) with clickable DOI citations, and high-fidelity PDF; update student SAP ID to 60018230100 and DJSCE college name
</commit_message>
<xml_diff>
--- a/00_Academic_Deliverables/FinReg_SLM_Slide_Deck_4.pptx
+++ b/00_Academic_Deliverables/FinReg_SLM_Slide_Deck_4.pptx
@@ -3304,7 +3304,7 @@
               </a:defRPr>
             </a:pPr>
             <a:r>
-              <a:t>• Student Name: Varun Gupta | SAP ID: 60004220055 | UID: 2022300055</a:t>
+              <a:t>• Student Name: Varun Gupta | SAP ID: 60018230100</a:t>
             </a:r>
           </a:p>
           <a:p>
@@ -3349,7 +3349,7 @@
               </a:defRPr>
             </a:pPr>
             <a:r>
-              <a:t>• Institution: SVKM's NMIMS, Mukesh Patel School of Technology Management &amp; Engineering (MPSTME)</a:t>
+              <a:t>• Institution: SVKM's Dwarkadas J. Sanghvi College of Engineering (DJSCE), Mumbai</a:t>
             </a:r>
           </a:p>
           <a:p>

</xml_diff>